<commit_message>
update XRD quantification with HighScore Plus
Use HighScore Plus 3.0 as the reported Rietveld quantification: 400 C = 96.3/3.7 wt% hematite/spinel; 600 C = 95.3/4.7 wt%. Update article table, methods, conclusions, HXP figure, and Avances slides; keep in-house model only as qualitative sanity check.
</commit_message>
<xml_diff>
--- a/article/Avances_MgFe2O4.pptx
+++ b/article/Avances_MgFe2O4.pptx
@@ -8244,30 +8244,6 @@
           </a:p>
         </p:txBody>
       </p:sp>
-      <p:pic>
-        <p:nvPicPr>
-          <p:cNvPr id="9" name="Picture 8" descr="xrd_easydiffraction.png"/>
-          <p:cNvPicPr>
-            <a:picLocks noChangeAspect="1"/>
-          </p:cNvPicPr>
-          <p:nvPr/>
-        </p:nvPicPr>
-        <p:blipFill>
-          <a:blip r:embed="rId2"/>
-          <a:stretch>
-            <a:fillRect/>
-          </a:stretch>
-        </p:blipFill>
-        <p:spPr>
-          <a:xfrm>
-            <a:off x="502920" y="1417320"/>
-            <a:ext cx="5186635" cy="4023360"/>
-          </a:xfrm>
-          <a:prstGeom prst="rect">
-            <a:avLst/>
-          </a:prstGeom>
-        </p:spPr>
-      </p:pic>
       <p:sp>
         <p:nvSpPr>
           <p:cNvPr id="10" name="TextBox 9"/>
@@ -8304,61 +8280,7 @@
                 </a:solidFill>
                 <a:latin typeface="Calibri"/>
               </a:rPr>
-              <a:t>Ajuste Rietveld con EasyDiffraction 0.21.1 (perfil TCH, doblete </a:t>
-            </a:r>
-            <a:r>
-              <a:rPr sz="1150" b="0" i="0">
-                <a:solidFill>
-                  <a:srgbClr val="5F5A52"/>
-                </a:solidFill>
-                <a:latin typeface="Calibri"/>
-              </a:rPr>
-              <a:t>Kα</a:t>
-            </a:r>
-            <a:r>
-              <a:rPr sz="759" b="0" i="0" baseline="-25000">
-                <a:solidFill>
-                  <a:srgbClr val="5F5A52"/>
-                </a:solidFill>
-                <a:latin typeface="Calibri"/>
-              </a:rPr>
-              <a:t>1</a:t>
-            </a:r>
-            <a:r>
-              <a:rPr sz="1150" b="0" i="0">
-                <a:solidFill>
-                  <a:srgbClr val="5F5A52"/>
-                </a:solidFill>
-                <a:latin typeface="Calibri"/>
-              </a:rPr>
-              <a:t>/</a:t>
-            </a:r>
-            <a:r>
-              <a:rPr sz="1150" b="0" i="0">
-                <a:solidFill>
-                  <a:srgbClr val="5F5A52"/>
-                </a:solidFill>
-                <a:latin typeface="Calibri"/>
-              </a:rPr>
-              <a:t>Kα</a:t>
-            </a:r>
-            <a:r>
-              <a:rPr sz="759" b="0" i="0" baseline="-25000">
-                <a:solidFill>
-                  <a:srgbClr val="5F5A52"/>
-                </a:solidFill>
-                <a:latin typeface="Calibri"/>
-              </a:rPr>
-              <a:t>2</a:t>
-            </a:r>
-            <a:r>
-              <a:rPr sz="1150" b="0" i="0">
-                <a:solidFill>
-                  <a:srgbClr val="5F5A52"/>
-                </a:solidFill>
-                <a:latin typeface="Calibri"/>
-              </a:rPr>
-              <a:t>, fondo Chebyshev): observado / calculado / diferencia.</a:t>
+              <a:t>Rietveld con HighScore Plus 3.0 (pseudo-Voigt, doblete Kα1/Kα2, fondo polinomial): perfil observado y posiciones de Bragg.</a:t>
             </a:r>
           </a:p>
         </p:txBody>
@@ -8833,34 +8755,7 @@
                 </a:solidFill>
                 <a:latin typeface="Calibri"/>
               </a:rPr>
-              <a:t>hematita 104 en 33.2°; espinela 220/400 en 30.1°/43.2°. No se detectó MgO ni </a:t>
-            </a:r>
-            <a:r>
-              <a:rPr sz="1300" b="0" i="0">
-                <a:solidFill>
-                  <a:srgbClr val="5F5A52"/>
-                </a:solidFill>
-                <a:latin typeface="Calibri"/>
-              </a:rPr>
-              <a:t>Mg(OH)</a:t>
-            </a:r>
-            <a:r>
-              <a:rPr sz="858" b="0" i="0" baseline="-25000">
-                <a:solidFill>
-                  <a:srgbClr val="5F5A52"/>
-                </a:solidFill>
-                <a:latin typeface="Calibri"/>
-              </a:rPr>
-              <a:t>2</a:t>
-            </a:r>
-            <a:r>
-              <a:rPr sz="1300" b="0" i="0">
-                <a:solidFill>
-                  <a:srgbClr val="5F5A52"/>
-                </a:solidFill>
-                <a:latin typeface="Calibri"/>
-              </a:rPr>
-              <a:t>.</a:t>
+              <a:t>hematita 104 en 33.2°; espinela 220/400 en 30.1°/43.2°. No se detectó MgO ni Mg(OH)2.</a:t>
             </a:r>
           </a:p>
           <a:p>
@@ -8879,7 +8774,7 @@
                 </a:solidFill>
                 <a:latin typeface="Calibri"/>
               </a:rPr>
-              <a:t>CIF seleccionados por criba cuantitativa: </a:t>
+              <a:t>Cuantificación HighScore Plus: </a:t>
             </a:r>
           </a:p>
           <a:p>
@@ -8898,7 +8793,7 @@
                 </a:solidFill>
                 <a:latin typeface="Calibri"/>
               </a:rPr>
-              <a:t>9015964.cif (R-3c) y 9001446.cif (Fd-3m).</a:t>
+              <a:t>hematita 96.3/95.3 %; espinela 3.7/4.7 % (400/600 °C).</a:t>
             </a:r>
           </a:p>
         </p:txBody>
@@ -8989,6 +8884,30 @@
           </a:p>
         </p:txBody>
       </p:sp>
+      <p:pic>
+        <p:nvPicPr>
+          <p:cNvPr id="21" name="Picture 20" descr="xrd_highscore.png"/>
+          <p:cNvPicPr>
+            <a:picLocks noChangeAspect="1"/>
+          </p:cNvPicPr>
+          <p:nvPr/>
+        </p:nvPicPr>
+        <p:blipFill>
+          <a:blip r:embed="rId3"/>
+          <a:stretch>
+            <a:fillRect/>
+          </a:stretch>
+        </p:blipFill>
+        <p:spPr>
+          <a:xfrm>
+            <a:off x="903091" y="1417320"/>
+            <a:ext cx="4386292" cy="4023360"/>
+          </a:xfrm>
+          <a:prstGeom prst="rect">
+            <a:avLst/>
+          </a:prstGeom>
+        </p:spPr>
+      </p:pic>
     </p:spTree>
   </p:cSld>
   <p:clrMapOvr>
@@ -9172,7 +9091,7 @@
                 </a:solidFill>
                 <a:latin typeface="Georgia"/>
               </a:rPr>
-              <a:t>Cuantificación (EasyDiffraction) y validación cruzada</a:t>
+              <a:t>Cuantificación (HighScore Plus) y cristalinidad</a:t>
             </a:r>
           </a:p>
         </p:txBody>
@@ -9410,7 +9329,7 @@
                           </a:solidFill>
                           <a:latin typeface="Calibri"/>
                         </a:rPr>
-                        <a:t>72.9</a:t>
+                        <a:t>96.3</a:t>
                       </a:r>
                     </a:p>
                   </a:txBody>
@@ -9438,7 +9357,7 @@
                           </a:solidFill>
                           <a:latin typeface="Calibri"/>
                         </a:rPr>
-                        <a:t>75.3</a:t>
+                        <a:t>95.3</a:t>
                       </a:r>
                     </a:p>
                   </a:txBody>
@@ -9468,52 +9387,7 @@
                           </a:solidFill>
                           <a:latin typeface="Calibri"/>
                         </a:rPr>
-                        <a:t>Espinela </a:t>
-                      </a:r>
-                      <a:r>
-                        <a:rPr sz="1250" b="1">
-                          <a:solidFill>
-                            <a:srgbClr val="2F6390"/>
-                          </a:solidFill>
-                          <a:latin typeface="Calibri"/>
-                        </a:rPr>
-                        <a:t>MgFe</a:t>
-                      </a:r>
-                      <a:r>
-                        <a:rPr sz="825" b="1" baseline="-25000">
-                          <a:solidFill>
-                            <a:srgbClr val="2F6390"/>
-                          </a:solidFill>
-                          <a:latin typeface="Calibri"/>
-                        </a:rPr>
-                        <a:t>2</a:t>
-                      </a:r>
-                      <a:r>
-                        <a:rPr sz="1250" b="1">
-                          <a:solidFill>
-                            <a:srgbClr val="2F6390"/>
-                          </a:solidFill>
-                          <a:latin typeface="Calibri"/>
-                        </a:rPr>
-                        <a:t>O</a:t>
-                      </a:r>
-                      <a:r>
-                        <a:rPr sz="825" b="1" baseline="-25000">
-                          <a:solidFill>
-                            <a:srgbClr val="2F6390"/>
-                          </a:solidFill>
-                          <a:latin typeface="Calibri"/>
-                        </a:rPr>
-                        <a:t>4</a:t>
-                      </a:r>
-                      <a:r>
-                        <a:rPr sz="1250" b="1">
-                          <a:solidFill>
-                            <a:srgbClr val="2F6390"/>
-                          </a:solidFill>
-                          <a:latin typeface="Calibri"/>
-                        </a:rPr>
-                        <a:t> (% peso)</a:t>
+                        <a:t>Espinela MgFe2O4 (% peso)</a:t>
                       </a:r>
                     </a:p>
                   </a:txBody>
@@ -9541,7 +9415,7 @@
                           </a:solidFill>
                           <a:latin typeface="Calibri"/>
                         </a:rPr>
-                        <a:t>27.1</a:t>
+                        <a:t>3.7</a:t>
                       </a:r>
                     </a:p>
                   </a:txBody>
@@ -9569,7 +9443,7 @@
                           </a:solidFill>
                           <a:latin typeface="Calibri"/>
                         </a:rPr>
-                        <a:t>24.7</a:t>
+                        <a:t>4.7</a:t>
                       </a:r>
                     </a:p>
                   </a:txBody>
@@ -9599,7 +9473,7 @@
                           </a:solidFill>
                           <a:latin typeface="Calibri"/>
                         </a:rPr>
-                        <a:t>Rwp / χ² (EasyDiffraction)</a:t>
+                        <a:t>Rwp / GOF (HighScore Plus)</a:t>
                       </a:r>
                     </a:p>
                   </a:txBody>
@@ -9627,7 +9501,7 @@
                           </a:solidFill>
                           <a:latin typeface="Calibri"/>
                         </a:rPr>
-                        <a:t>3.92 % / 5.17</a:t>
+                        <a:t>1.46 % / 0.72</a:t>
                       </a:r>
                     </a:p>
                   </a:txBody>
@@ -9655,7 +9529,7 @@
                           </a:solidFill>
                           <a:latin typeface="Calibri"/>
                         </a:rPr>
-                        <a:t>5.27 % / 8.45</a:t>
+                        <a:t>1.54 % / 0.72</a:t>
                       </a:r>
                     </a:p>
                   </a:txBody>
@@ -9685,7 +9559,7 @@
                           </a:solidFill>
                           <a:latin typeface="Calibri"/>
                         </a:rPr>
-                        <a:t>Rwp (modelo in-house)</a:t>
+                        <a:t>a hematita (Å)</a:t>
                       </a:r>
                     </a:p>
                   </a:txBody>
@@ -9713,7 +9587,7 @@
                           </a:solidFill>
                           <a:latin typeface="Calibri"/>
                         </a:rPr>
-                        <a:t>1.08 %</a:t>
+                        <a:t>5.0378</a:t>
                       </a:r>
                     </a:p>
                   </a:txBody>
@@ -9741,7 +9615,7 @@
                           </a:solidFill>
                           <a:latin typeface="Calibri"/>
                         </a:rPr>
-                        <a:t>1.30 %</a:t>
+                        <a:t>5.0358</a:t>
                       </a:r>
                     </a:p>
                   </a:txBody>
@@ -9771,16 +9645,7 @@
                           </a:solidFill>
                           <a:latin typeface="Calibri"/>
                         </a:rPr>
-                        <a:t>a</a:t>
-                      </a:r>
-                      <a:r>
-                        <a:rPr sz="1250" b="1" i="0">
-                          <a:solidFill>
-                            <a:srgbClr val="23262B"/>
-                          </a:solidFill>
-                          <a:latin typeface="Calibri"/>
-                        </a:rPr>
-                        <a:t> hematita (Å)</a:t>
+                        <a:t>c hematita (Å)</a:t>
                       </a:r>
                     </a:p>
                   </a:txBody>
@@ -9808,7 +9673,7 @@
                           </a:solidFill>
                           <a:latin typeface="Calibri"/>
                         </a:rPr>
-                        <a:t>5.0501</a:t>
+                        <a:t>13.759</a:t>
                       </a:r>
                     </a:p>
                   </a:txBody>
@@ -9836,7 +9701,7 @@
                           </a:solidFill>
                           <a:latin typeface="Calibri"/>
                         </a:rPr>
-                        <a:t>5.0420</a:t>
+                        <a:t>13.746</a:t>
                       </a:r>
                     </a:p>
                   </a:txBody>
@@ -9866,16 +9731,7 @@
                           </a:solidFill>
                           <a:latin typeface="Calibri"/>
                         </a:rPr>
-                        <a:t>a</a:t>
-                      </a:r>
-                      <a:r>
-                        <a:rPr sz="1250" b="1" i="0">
-                          <a:solidFill>
-                            <a:srgbClr val="23262B"/>
-                          </a:solidFill>
-                          <a:latin typeface="Calibri"/>
-                        </a:rPr>
-                        <a:t> espinela (Å)</a:t>
+                        <a:t>a espinela (Å)</a:t>
                       </a:r>
                     </a:p>
                   </a:txBody>
@@ -9903,7 +9759,7 @@
                           </a:solidFill>
                           <a:latin typeface="Calibri"/>
                         </a:rPr>
-                        <a:t>8.3979</a:t>
+                        <a:t>8.350</a:t>
                       </a:r>
                     </a:p>
                   </a:txBody>
@@ -9931,7 +9787,7 @@
                           </a:solidFill>
                           <a:latin typeface="Calibri"/>
                         </a:rPr>
-                        <a:t>8.3906</a:t>
+                        <a:t>8.381</a:t>
                       </a:r>
                     </a:p>
                   </a:txBody>
@@ -10249,7 +10105,7 @@
                 </a:solidFill>
                 <a:latin typeface="Calibri"/>
               </a:rPr>
-              <a:t>¿Por qué se privilegia EasyDiffraction?</a:t>
+              <a:t>¿Por qué se privilegia HighScore Plus?</a:t>
             </a:r>
           </a:p>
           <a:p>
@@ -10268,34 +10124,7 @@
                 </a:solidFill>
                 <a:latin typeface="Calibri"/>
               </a:rPr>
-              <a:t>Es un motor Rietveld completo (TCH U/V/W, </a:t>
-            </a:r>
-            <a:r>
-              <a:rPr sz="1500" b="0" i="0">
-                <a:solidFill>
-                  <a:srgbClr val="23262B"/>
-                </a:solidFill>
-                <a:latin typeface="Calibri"/>
-              </a:rPr>
-              <a:t>Kα</a:t>
-            </a:r>
-            <a:r>
-              <a:rPr sz="990" b="0" i="0" baseline="-25000">
-                <a:solidFill>
-                  <a:srgbClr val="23262B"/>
-                </a:solidFill>
-                <a:latin typeface="Calibri"/>
-              </a:rPr>
-              <a:t>2</a:t>
-            </a:r>
-            <a:r>
-              <a:rPr sz="1500" b="0" i="0">
-                <a:solidFill>
-                  <a:srgbClr val="23262B"/>
-                </a:solidFill>
-                <a:latin typeface="Calibri"/>
-              </a:rPr>
-              <a:t>, pesos √y). Las fracciones en peso usan el factor estándar de Hill–Howard W ~ S·Z·M·V.</a:t>
+              <a:t>Es un motor Rietveld completo (pseudo-Voigt, doblete Kα1/Kα2, fondo polinomial). Las fracciones en peso usan el factor de Hill–Howard W ∝ S·Z·M·V.</a:t>
             </a:r>
           </a:p>
           <a:p>
@@ -10314,16 +10143,7 @@
                 </a:solidFill>
                 <a:latin typeface="Calibri"/>
               </a:rPr>
-              <a:t>Validación cruzada: </a:t>
-            </a:r>
-            <a:r>
-              <a:rPr sz="1300" b="0" i="0">
-                <a:solidFill>
-                  <a:srgbClr val="5F5A52"/>
-                </a:solidFill>
-                <a:latin typeface="Calibri"/>
-              </a:rPr>
-              <a:t>el modelo in-house (pseudo-Voigt, un FWHM) reproduce las mismas fases y celdas (Δa &lt; 0.02 Å) con Rwp = 1.1–1.3 %.</a:t>
+              <a:t>Control in-house: un modelo mínimo (pseudo-Voigt, un FWHM) reprodujo las mismas fases y confirmó la dominancia de hematita; no se usó para cuantificar.</a:t>
             </a:r>
           </a:p>
           <a:p>
@@ -10342,16 +10162,7 @@
                 </a:solidFill>
                 <a:latin typeface="Calibri"/>
               </a:rPr>
-              <a:t>Lectura: </a:t>
-            </a:r>
-            <a:r>
-              <a:rPr sz="1300" b="0" i="0">
-                <a:solidFill>
-                  <a:srgbClr val="5F5A52"/>
-                </a:solidFill>
-                <a:latin typeface="Calibri"/>
-              </a:rPr>
-              <a:t>la recalc a 600 °C no cambia la fracción de fases, pero duplica la cristalinidad (FWHM se reduce a la mitad; D: 18 → 29 nm).</a:t>
+              <a:t>Lectura: hematita ≈ 95–96 % y espinela ≈ 4–5 % en ambas pasadas. La recalc a 600 °C no cambia la fase mayoritaria, pero reduce el FWHM a la mitad (D: 18 → 29 nm).</a:t>
             </a:r>
           </a:p>
         </p:txBody>
@@ -13780,16 +13591,7 @@
                 </a:solidFill>
                 <a:latin typeface="Calibri"/>
               </a:rPr>
-              <a:t>• </a:t>
-            </a:r>
-            <a:r>
-              <a:rPr sz="1400" b="0" i="0">
-                <a:solidFill>
-                  <a:srgbClr val="23262B"/>
-                </a:solidFill>
-                <a:latin typeface="Calibri"/>
-              </a:rPr>
-              <a:t>La muestra NO es espinela pura: mezcla ≈ 73–75 % hematita + ≈ 25–27 % espinela (EasyDiffraction, χ² = 5.2–8.4).</a:t>
+              <a:t>• La muestra NO es espinela pura: mezcla ≈ 95–96 % hematita + ≈ 4–5 % espinela (HighScore Plus, Rwp 1.46–1.54 %, GOF ≈ 0.72).</a:t>
             </a:r>
           </a:p>
           <a:p>
@@ -13808,16 +13610,7 @@
                 </a:solidFill>
                 <a:latin typeface="Calibri"/>
               </a:rPr>
-              <a:t>• </a:t>
-            </a:r>
-            <a:r>
-              <a:rPr sz="1400" b="0" i="0">
-                <a:solidFill>
-                  <a:srgbClr val="23262B"/>
-                </a:solidFill>
-                <a:latin typeface="Calibri"/>
-              </a:rPr>
-              <a:t>Recalcinación a 600 °C: misma fracción de fases, pero FWHM 0.474° → 0.275° y cristalitos 18 → 29 nm (mayor cristalinidad).</a:t>
+              <a:t>• Recalcinación a 600 °C: no cambia la fase mayoritaria; FWHM 0.474° → 0.275° y cristalitos 18 → 29 nm (mayor cristalinidad).</a:t>
             </a:r>
           </a:p>
           <a:p>
@@ -13836,16 +13629,7 @@
                 </a:solidFill>
                 <a:latin typeface="Calibri"/>
               </a:rPr>
-              <a:t>• </a:t>
-            </a:r>
-            <a:r>
-              <a:rPr sz="1400" b="0" i="0">
-                <a:solidFill>
-                  <a:srgbClr val="23262B"/>
-                </a:solidFill>
-                <a:latin typeface="Calibri"/>
-              </a:rPr>
-              <a:t>Tauc con dos líneas = dos fases: espinela ≈ 1.6 eV, hematita ≈ 2.0 eV.</a:t>
+              <a:t>• Tauc con dos líneas = dos fases: espinela ≈ 1.6 eV, hematita ≈ 2.0 eV.</a:t>
             </a:r>
           </a:p>
           <a:p>
@@ -13864,16 +13648,7 @@
                 </a:solidFill>
                 <a:latin typeface="Calibri"/>
               </a:rPr>
-              <a:t>• </a:t>
-            </a:r>
-            <a:r>
-              <a:rPr sz="1400" b="0" i="0">
-                <a:solidFill>
-                  <a:srgbClr val="23262B"/>
-                </a:solidFill>
-                <a:latin typeface="Calibri"/>
-              </a:rPr>
-              <a:t>Granos SEM 141 ± 2.4 nm = aglomerados de ~5–7 cristalitos DRX.</a:t>
+              <a:t>• Granos SEM 141 ± 2.4 nm = aglomerados de ~5–7 cristalitos DRX.</a:t>
             </a:r>
           </a:p>
           <a:p>
@@ -13892,16 +13667,7 @@
                 </a:solidFill>
                 <a:latin typeface="Calibri"/>
               </a:rPr>
-              <a:t>• </a:t>
-            </a:r>
-            <a:r>
-              <a:rPr sz="1400" b="0" i="0">
-                <a:solidFill>
-                  <a:srgbClr val="23262B"/>
-                </a:solidFill>
-                <a:latin typeface="Calibri"/>
-              </a:rPr>
-              <a:t>EDS subestima Mg (Fe:Mg ≈ 69:1 vs 4.6:1); el Mg está en la espinela minoritaria.</a:t>
+              <a:t>• EDS subestima Mg (Fe:Mg ≈ 69:1 vs 4.6:1); el Mg está en la espinela minoritaria.</a:t>
             </a:r>
           </a:p>
         </p:txBody>
@@ -14086,16 +13852,7 @@
                 </a:solidFill>
                 <a:latin typeface="Calibri"/>
               </a:rPr>
-              <a:t>• </a:t>
-            </a:r>
-            <a:r>
-              <a:rPr sz="1400" b="0" i="0">
-                <a:solidFill>
-                  <a:srgbClr val="23262B"/>
-                </a:solidFill>
-                <a:latin typeface="Calibri"/>
-              </a:rPr>
-              <a:t>Refinar en EasyDiffraction con March–Dollase y términos TCH de tamaño/deformación separados.</a:t>
+              <a:t>• Refinar en HighScore Plus con March–Dollase y términos de tamaño/deformación separados.</a:t>
             </a:r>
           </a:p>
           <a:p>

</xml_diff>